<commit_message>
Presentation v3: Scam Shield product slide, updated title and roadmap
Co-Authored-By: Claude Fable 5 <noreply@anthropic.com>
Claude-Session: https://claude.ai/code/session_01B3RdY6E8fVkYQkHX44hiEi
</commit_message>
<xml_diff>
--- a/docs/PhishGuard_Presentation_Final.pptx
+++ b/docs/PhishGuard_Presentation_Final.pptx
@@ -16,6 +16,7 @@
     <p:sldId id="261" r:id="rId7"/>
     <p:sldId id="262" r:id="rId8"/>
     <p:sldId id="264" r:id="rId15"/>
+    <p:sldId id="265" r:id="rId16"/>
     <p:sldId id="263" r:id="rId9"/>
   </p:sldIdLst>
   <p:sldSz cx="12192000" cy="6858000"/>
@@ -1477,7 +1478,7 @@
                 <a:ea typeface="Cambria" pitchFamily="34" charset="-122"/>
                 <a:cs typeface="Cambria" pitchFamily="34" charset="-120"/>
               </a:rPr>
-              <a:t>(URL + Email) with Real-Time Dashboard</a:t>
+              <a:t>(URLs, Messages &amp; QR Payments) — On-Device Extension + Live Dashboard</a:t>
             </a:r>
             <a:endParaRPr lang="en-US" sz="3400" dirty="0"/>
           </a:p>
@@ -1519,6 +1520,964 @@
               <a:t>What if we could stop phishing before the click?</a:t>
             </a:r>
             <a:endParaRPr lang="en-US" sz="1600" dirty="0"/>
+          </a:p>
+        </p:txBody>
+      </p:sp>
+    </p:spTree>
+  </p:cSld>
+  <p:clrMapOvr>
+    <a:masterClrMapping/>
+  </p:clrMapOvr>
+</p:sld>
+</file>
+
+<file path=ppt/slides/slide10.xml><?xml version="1.0" encoding="utf-8"?>
+<p:sld xmlns:a="http://schemas.openxmlformats.org/drawingml/2006/main" xmlns:r="http://schemas.openxmlformats.org/officeDocument/2006/relationships" xmlns:p="http://schemas.openxmlformats.org/presentationml/2006/main">
+  <p:cSld name="Slide 7">
+    <p:bg>
+      <p:bgPr>
+        <a:solidFill>
+          <a:srgbClr val="FFFFFF"/>
+        </a:solidFill>
+        <a:effectLst/>
+      </p:bgPr>
+    </p:bg>
+    <p:spTree>
+      <p:nvGrpSpPr>
+        <p:cNvPr id="1" name=""/>
+        <p:cNvGrpSpPr/>
+        <p:nvPr/>
+      </p:nvGrpSpPr>
+      <p:grpSpPr>
+        <a:xfrm>
+          <a:off x="0" y="0"/>
+          <a:ext cx="0" cy="0"/>
+          <a:chOff x="0" y="0"/>
+          <a:chExt cx="0" cy="0"/>
+        </a:xfrm>
+      </p:grpSpPr>
+      <p:sp>
+        <p:nvSpPr>
+          <p:cNvPr id="2" name="Text 0"/>
+          <p:cNvSpPr/>
+          <p:nvPr/>
+        </p:nvSpPr>
+        <p:spPr>
+          <a:xfrm>
+            <a:off x="502920" y="411480"/>
+            <a:ext cx="7315200" cy="640080"/>
+          </a:xfrm>
+          <a:prstGeom prst="rect">
+            <a:avLst/>
+          </a:prstGeom>
+          <a:noFill/>
+          <a:ln/>
+        </p:spPr>
+        <p:txBody>
+          <a:bodyPr wrap="square" rtlCol="0" anchor="ctr"/>
+          <a:lstStyle/>
+          <a:p>
+            <a:pPr marL="0" indent="0">
+              <a:buNone/>
+            </a:pPr>
+            <a:r>
+              <a:rPr lang="en-US" sz="3400" b="1" dirty="0">
+                <a:solidFill>
+                  <a:srgbClr val="0B1F3A"/>
+                </a:solidFill>
+                <a:latin typeface="Cambria" pitchFamily="34" charset="0"/>
+                <a:ea typeface="Cambria" pitchFamily="34" charset="-122"/>
+                <a:cs typeface="Cambria" pitchFamily="34" charset="-120"/>
+              </a:rPr>
+              <a:t>SCAM SHIELD — THE PRODUCT</a:t>
+            </a:r>
+            <a:endParaRPr lang="en-US" sz="3400" dirty="0"/>
+          </a:p>
+        </p:txBody>
+      </p:sp>
+      <p:sp>
+        <p:nvSpPr>
+          <p:cNvPr id="3" name="Shape 1"/>
+          <p:cNvSpPr/>
+          <p:nvPr/>
+        </p:nvSpPr>
+        <p:spPr>
+          <a:xfrm>
+            <a:off x="530352" y="1051560"/>
+            <a:ext cx="502920" cy="54864"/>
+          </a:xfrm>
+          <a:prstGeom prst="roundRect">
+            <a:avLst>
+              <a:gd name="adj" fmla="val 50000"/>
+            </a:avLst>
+          </a:prstGeom>
+          <a:solidFill>
+            <a:srgbClr val="2E86FF"/>
+          </a:solidFill>
+          <a:ln/>
+        </p:spPr>
+      </p:sp>
+      <p:sp>
+        <p:nvSpPr>
+          <p:cNvPr id="4" name="Shape 2"/>
+          <p:cNvSpPr/>
+          <p:nvPr/>
+        </p:nvSpPr>
+        <p:spPr>
+          <a:xfrm>
+            <a:off x="502920" y="1417320"/>
+            <a:ext cx="3611880" cy="2331720"/>
+          </a:xfrm>
+          <a:prstGeom prst="roundRect">
+            <a:avLst>
+              <a:gd name="adj" fmla="val 3137"/>
+            </a:avLst>
+          </a:prstGeom>
+          <a:solidFill>
+            <a:srgbClr val="F4F8FC"/>
+          </a:solidFill>
+          <a:ln/>
+        </p:spPr>
+      </p:sp>
+      <p:sp>
+        <p:nvSpPr>
+          <p:cNvPr id="5" name="Shape 3"/>
+          <p:cNvSpPr/>
+          <p:nvPr/>
+        </p:nvSpPr>
+        <p:spPr>
+          <a:xfrm>
+            <a:off x="1965960" y="1673352"/>
+            <a:ext cx="685800" cy="685800"/>
+          </a:xfrm>
+          <a:prstGeom prst="ellipse">
+            <a:avLst/>
+          </a:prstGeom>
+          <a:solidFill>
+            <a:srgbClr val="2E86FF"/>
+          </a:solidFill>
+          <a:ln/>
+        </p:spPr>
+      </p:sp>
+      <p:pic>
+        <p:nvPicPr>
+          <p:cNvPr id="6" name="Image 0" descr="/home/claude/icons/check.png"/>
+          <p:cNvPicPr>
+            <a:picLocks noChangeAspect="1"/>
+          </p:cNvPicPr>
+          <p:nvPr/>
+        </p:nvPicPr>
+        <p:blipFill>
+          <a:blip r:embed="rId3"/>
+          <a:stretch>
+            <a:fillRect/>
+          </a:stretch>
+        </p:blipFill>
+        <p:spPr>
+          <a:xfrm>
+            <a:off x="2144268" y="1851660"/>
+            <a:ext cx="329184" cy="329184"/>
+          </a:xfrm>
+          <a:prstGeom prst="rect">
+            <a:avLst/>
+          </a:prstGeom>
+        </p:spPr>
+      </p:pic>
+      <p:sp>
+        <p:nvSpPr>
+          <p:cNvPr id="7" name="Text 4"/>
+          <p:cNvSpPr/>
+          <p:nvPr/>
+        </p:nvSpPr>
+        <p:spPr>
+          <a:xfrm>
+            <a:off x="685800" y="2468880"/>
+            <a:ext cx="3246120" cy="457200"/>
+          </a:xfrm>
+          <a:prstGeom prst="rect">
+            <a:avLst/>
+          </a:prstGeom>
+          <a:noFill/>
+          <a:ln/>
+        </p:spPr>
+        <p:txBody>
+          <a:bodyPr wrap="square" rtlCol="0" anchor="ctr"/>
+          <a:lstStyle/>
+          <a:p>
+            <a:pPr marL="0" indent="0" algn="ctr">
+              <a:buNone/>
+            </a:pPr>
+            <a:r>
+              <a:rPr lang="en-US" sz="1350" b="1" dirty="0">
+                <a:solidFill>
+                  <a:srgbClr val="0B1F3A"/>
+                </a:solidFill>
+                <a:latin typeface="Calibri" pitchFamily="34" charset="0"/>
+                <a:ea typeface="Calibri" pitchFamily="34" charset="-122"/>
+                <a:cs typeface="Calibri" pitchFamily="34" charset="-120"/>
+              </a:rPr>
+              <a:t>On-Device Browser Extension</a:t>
+            </a:r>
+            <a:endParaRPr lang="en-US" sz="1350" dirty="0"/>
+          </a:p>
+        </p:txBody>
+      </p:sp>
+      <p:sp>
+        <p:nvSpPr>
+          <p:cNvPr id="8" name="Text 5"/>
+          <p:cNvSpPr/>
+          <p:nvPr/>
+        </p:nvSpPr>
+        <p:spPr>
+          <a:xfrm>
+            <a:off x="731520" y="2898648"/>
+            <a:ext cx="3154680" cy="777240"/>
+          </a:xfrm>
+          <a:prstGeom prst="rect">
+            <a:avLst/>
+          </a:prstGeom>
+          <a:noFill/>
+          <a:ln/>
+        </p:spPr>
+        <p:txBody>
+          <a:bodyPr wrap="square" rtlCol="0" anchor="t"/>
+          <a:lstStyle/>
+          <a:p>
+            <a:pPr marL="0" indent="0" algn="ctr">
+              <a:buNone/>
+            </a:pPr>
+            <a:r>
+              <a:rPr lang="en-US" sz="1050" dirty="0">
+                <a:solidFill>
+                  <a:srgbClr val="5B6B82"/>
+                </a:solidFill>
+                <a:latin typeface="Calibri" pitchFamily="34" charset="0"/>
+                <a:ea typeface="Calibri" pitchFamily="34" charset="-122"/>
+                <a:cs typeface="Calibri" pitchFamily="34" charset="-120"/>
+              </a:rPr>
+              <a:t>The full ML detector in 2.7 MB of JavaScript — blocks phishing pages in ~1 ms, 100% offline.</a:t>
+            </a:r>
+            <a:endParaRPr lang="en-US" sz="1050" dirty="0"/>
+          </a:p>
+        </p:txBody>
+      </p:sp>
+      <p:sp>
+        <p:nvSpPr>
+          <p:cNvPr id="9" name="Shape 6"/>
+          <p:cNvSpPr/>
+          <p:nvPr/>
+        </p:nvSpPr>
+        <p:spPr>
+          <a:xfrm>
+            <a:off x="4297680" y="1426651"/>
+            <a:ext cx="3611880" cy="2331720"/>
+          </a:xfrm>
+          <a:prstGeom prst="roundRect">
+            <a:avLst>
+              <a:gd name="adj" fmla="val 3137"/>
+            </a:avLst>
+          </a:prstGeom>
+          <a:solidFill>
+            <a:srgbClr val="F4F8FC"/>
+          </a:solidFill>
+          <a:ln/>
+        </p:spPr>
+      </p:sp>
+      <p:sp>
+        <p:nvSpPr>
+          <p:cNvPr id="10" name="Shape 7"/>
+          <p:cNvSpPr/>
+          <p:nvPr/>
+        </p:nvSpPr>
+        <p:spPr>
+          <a:xfrm>
+            <a:off x="5760720" y="1673352"/>
+            <a:ext cx="685800" cy="685800"/>
+          </a:xfrm>
+          <a:prstGeom prst="ellipse">
+            <a:avLst/>
+          </a:prstGeom>
+          <a:solidFill>
+            <a:srgbClr val="2E86FF"/>
+          </a:solidFill>
+          <a:ln/>
+        </p:spPr>
+      </p:sp>
+      <p:pic>
+        <p:nvPicPr>
+          <p:cNvPr id="11" name="Image 1" descr="/home/claude/icons/ban.png"/>
+          <p:cNvPicPr>
+            <a:picLocks noChangeAspect="1"/>
+          </p:cNvPicPr>
+          <p:nvPr/>
+        </p:nvPicPr>
+        <p:blipFill>
+          <a:blip r:embed="rId4"/>
+          <a:stretch>
+            <a:fillRect/>
+          </a:stretch>
+        </p:blipFill>
+        <p:spPr>
+          <a:xfrm>
+            <a:off x="5939028" y="1851660"/>
+            <a:ext cx="329184" cy="329184"/>
+          </a:xfrm>
+          <a:prstGeom prst="rect">
+            <a:avLst/>
+          </a:prstGeom>
+        </p:spPr>
+      </p:pic>
+      <p:sp>
+        <p:nvSpPr>
+          <p:cNvPr id="12" name="Text 8"/>
+          <p:cNvSpPr/>
+          <p:nvPr/>
+        </p:nvSpPr>
+        <p:spPr>
+          <a:xfrm>
+            <a:off x="4480560" y="2468880"/>
+            <a:ext cx="3246120" cy="457200"/>
+          </a:xfrm>
+          <a:prstGeom prst="rect">
+            <a:avLst/>
+          </a:prstGeom>
+          <a:noFill/>
+          <a:ln/>
+        </p:spPr>
+        <p:txBody>
+          <a:bodyPr wrap="square" rtlCol="0" anchor="ctr"/>
+          <a:lstStyle/>
+          <a:p>
+            <a:pPr marL="0" indent="0" algn="ctr">
+              <a:buNone/>
+            </a:pPr>
+            <a:r>
+              <a:rPr lang="en-US" sz="1350" b="1" dirty="0">
+                <a:solidFill>
+                  <a:srgbClr val="0B1F3A"/>
+                </a:solidFill>
+                <a:latin typeface="Calibri" pitchFamily="34" charset="0"/>
+                <a:ea typeface="Calibri" pitchFamily="34" charset="-122"/>
+                <a:cs typeface="Calibri" pitchFamily="34" charset="-120"/>
+              </a:rPr>
+              <a:t>Look-Alike Domain Catcher</a:t>
+            </a:r>
+            <a:endParaRPr lang="en-US" sz="1350" dirty="0"/>
+          </a:p>
+        </p:txBody>
+      </p:sp>
+      <p:sp>
+        <p:nvSpPr>
+          <p:cNvPr id="13" name="Text 9"/>
+          <p:cNvSpPr/>
+          <p:nvPr/>
+        </p:nvSpPr>
+        <p:spPr>
+          <a:xfrm>
+            <a:off x="4526280" y="2898648"/>
+            <a:ext cx="3154680" cy="777240"/>
+          </a:xfrm>
+          <a:prstGeom prst="rect">
+            <a:avLst/>
+          </a:prstGeom>
+          <a:noFill/>
+          <a:ln/>
+        </p:spPr>
+        <p:txBody>
+          <a:bodyPr wrap="square" rtlCol="0" anchor="t"/>
+          <a:lstStyle/>
+          <a:p>
+            <a:pPr marL="0" indent="0" algn="ctr">
+              <a:buNone/>
+            </a:pPr>
+            <a:r>
+              <a:rPr lang="en-US" sz="1050" dirty="0">
+                <a:solidFill>
+                  <a:srgbClr val="5B6B82"/>
+                </a:solidFill>
+                <a:latin typeface="Calibri" pitchFamily="34" charset="0"/>
+                <a:ea typeface="Calibri" pitchFamily="34" charset="-122"/>
+                <a:cs typeface="Calibri" pitchFamily="34" charset="-120"/>
+              </a:rPr>
+              <a:t>Homoglyph + edit-distance analysis exposes paypa1.com, arnazon.com and paypal.support instantly.</a:t>
+            </a:r>
+            <a:endParaRPr lang="en-US" sz="1050" dirty="0"/>
+          </a:p>
+        </p:txBody>
+      </p:sp>
+      <p:sp>
+        <p:nvSpPr>
+          <p:cNvPr id="14" name="Shape 10"/>
+          <p:cNvSpPr/>
+          <p:nvPr/>
+        </p:nvSpPr>
+        <p:spPr>
+          <a:xfrm>
+            <a:off x="8092440" y="1417320"/>
+            <a:ext cx="3611880" cy="2331720"/>
+          </a:xfrm>
+          <a:prstGeom prst="roundRect">
+            <a:avLst>
+              <a:gd name="adj" fmla="val 3137"/>
+            </a:avLst>
+          </a:prstGeom>
+          <a:solidFill>
+            <a:srgbClr val="F4F8FC"/>
+          </a:solidFill>
+          <a:ln/>
+        </p:spPr>
+      </p:sp>
+      <p:sp>
+        <p:nvSpPr>
+          <p:cNvPr id="15" name="Shape 11"/>
+          <p:cNvSpPr/>
+          <p:nvPr/>
+        </p:nvSpPr>
+        <p:spPr>
+          <a:xfrm>
+            <a:off x="9555480" y="1673352"/>
+            <a:ext cx="685800" cy="685800"/>
+          </a:xfrm>
+          <a:prstGeom prst="ellipse">
+            <a:avLst/>
+          </a:prstGeom>
+          <a:solidFill>
+            <a:srgbClr val="2E86FF"/>
+          </a:solidFill>
+          <a:ln/>
+        </p:spPr>
+      </p:sp>
+      <p:pic>
+        <p:nvPicPr>
+          <p:cNvPr id="16" name="Image 2" descr="/home/claude/icons/bolt.png"/>
+          <p:cNvPicPr>
+            <a:picLocks noChangeAspect="1"/>
+          </p:cNvPicPr>
+          <p:nvPr/>
+        </p:nvPicPr>
+        <p:blipFill>
+          <a:blip r:embed="rId5"/>
+          <a:stretch>
+            <a:fillRect/>
+          </a:stretch>
+        </p:blipFill>
+        <p:spPr>
+          <a:xfrm>
+            <a:off x="9733788" y="1851660"/>
+            <a:ext cx="329184" cy="329184"/>
+          </a:xfrm>
+          <a:prstGeom prst="rect">
+            <a:avLst/>
+          </a:prstGeom>
+        </p:spPr>
+      </p:pic>
+      <p:sp>
+        <p:nvSpPr>
+          <p:cNvPr id="17" name="Text 12"/>
+          <p:cNvSpPr/>
+          <p:nvPr/>
+        </p:nvSpPr>
+        <p:spPr>
+          <a:xfrm>
+            <a:off x="8275320" y="2468880"/>
+            <a:ext cx="3246120" cy="457200"/>
+          </a:xfrm>
+          <a:prstGeom prst="rect">
+            <a:avLst/>
+          </a:prstGeom>
+          <a:noFill/>
+          <a:ln/>
+        </p:spPr>
+        <p:txBody>
+          <a:bodyPr wrap="square" rtlCol="0" anchor="ctr"/>
+          <a:lstStyle/>
+          <a:p>
+            <a:pPr marL="0" indent="0" algn="ctr">
+              <a:buNone/>
+            </a:pPr>
+            <a:r>
+              <a:rPr lang="en-US" sz="1350" b="1" dirty="0">
+                <a:solidFill>
+                  <a:srgbClr val="0B1F3A"/>
+                </a:solidFill>
+                <a:latin typeface="Calibri" pitchFamily="34" charset="0"/>
+                <a:ea typeface="Calibri" pitchFamily="34" charset="-122"/>
+                <a:cs typeface="Calibri" pitchFamily="34" charset="-120"/>
+              </a:rPr>
+              <a:t>Scam Message Analyzer</a:t>
+            </a:r>
+            <a:endParaRPr lang="en-US" sz="1350" dirty="0"/>
+          </a:p>
+        </p:txBody>
+      </p:sp>
+      <p:sp>
+        <p:nvSpPr>
+          <p:cNvPr id="18" name="Text 13"/>
+          <p:cNvSpPr/>
+          <p:nvPr/>
+        </p:nvSpPr>
+        <p:spPr>
+          <a:xfrm>
+            <a:off x="8321040" y="2898648"/>
+            <a:ext cx="3154680" cy="777240"/>
+          </a:xfrm>
+          <a:prstGeom prst="rect">
+            <a:avLst/>
+          </a:prstGeom>
+          <a:noFill/>
+          <a:ln/>
+        </p:spPr>
+        <p:txBody>
+          <a:bodyPr wrap="square" rtlCol="0" anchor="t"/>
+          <a:lstStyle/>
+          <a:p>
+            <a:pPr marL="0" indent="0" algn="ctr">
+              <a:buNone/>
+            </a:pPr>
+            <a:r>
+              <a:rPr lang="en-US" sz="1050" dirty="0">
+                <a:solidFill>
+                  <a:srgbClr val="5B6B82"/>
+                </a:solidFill>
+                <a:latin typeface="Calibri" pitchFamily="34" charset="0"/>
+                <a:ea typeface="Calibri" pitchFamily="34" charset="-122"/>
+                <a:cs typeface="Calibri" pitchFamily="34" charset="-120"/>
+              </a:rPr>
+              <a:t>Paste any SMS or WhatsApp text — it names the scam (KYC, job fee, courier, OTP theft) and says what to do.</a:t>
+            </a:r>
+            <a:endParaRPr lang="en-US" sz="1050" dirty="0"/>
+          </a:p>
+        </p:txBody>
+      </p:sp>
+      <p:sp>
+        <p:nvSpPr>
+          <p:cNvPr id="19" name="Shape 14"/>
+          <p:cNvSpPr/>
+          <p:nvPr/>
+        </p:nvSpPr>
+        <p:spPr>
+          <a:xfrm>
+            <a:off x="502920" y="3977640"/>
+            <a:ext cx="3611880" cy="2331720"/>
+          </a:xfrm>
+          <a:prstGeom prst="roundRect">
+            <a:avLst>
+              <a:gd name="adj" fmla="val 3137"/>
+            </a:avLst>
+          </a:prstGeom>
+          <a:solidFill>
+            <a:srgbClr val="F4F8FC"/>
+          </a:solidFill>
+          <a:ln/>
+        </p:spPr>
+      </p:sp>
+      <p:sp>
+        <p:nvSpPr>
+          <p:cNvPr id="20" name="Shape 15"/>
+          <p:cNvSpPr/>
+          <p:nvPr/>
+        </p:nvSpPr>
+        <p:spPr>
+          <a:xfrm>
+            <a:off x="1965960" y="4233672"/>
+            <a:ext cx="685800" cy="685800"/>
+          </a:xfrm>
+          <a:prstGeom prst="ellipse">
+            <a:avLst/>
+          </a:prstGeom>
+          <a:solidFill>
+            <a:srgbClr val="2E86FF"/>
+          </a:solidFill>
+          <a:ln/>
+        </p:spPr>
+      </p:sp>
+      <p:pic>
+        <p:nvPicPr>
+          <p:cNvPr id="21" name="Image 3" descr="/home/claude/icons/brain.png"/>
+          <p:cNvPicPr>
+            <a:picLocks noChangeAspect="1"/>
+          </p:cNvPicPr>
+          <p:nvPr/>
+        </p:nvPicPr>
+        <p:blipFill>
+          <a:blip r:embed="rId6"/>
+          <a:stretch>
+            <a:fillRect/>
+          </a:stretch>
+        </p:blipFill>
+        <p:spPr>
+          <a:xfrm>
+            <a:off x="2144268" y="4411980"/>
+            <a:ext cx="329184" cy="329184"/>
+          </a:xfrm>
+          <a:prstGeom prst="rect">
+            <a:avLst/>
+          </a:prstGeom>
+        </p:spPr>
+      </p:pic>
+      <p:sp>
+        <p:nvSpPr>
+          <p:cNvPr id="22" name="Text 16"/>
+          <p:cNvSpPr/>
+          <p:nvPr/>
+        </p:nvSpPr>
+        <p:spPr>
+          <a:xfrm>
+            <a:off x="685800" y="5029200"/>
+            <a:ext cx="3246120" cy="457200"/>
+          </a:xfrm>
+          <a:prstGeom prst="rect">
+            <a:avLst/>
+          </a:prstGeom>
+          <a:noFill/>
+          <a:ln/>
+        </p:spPr>
+        <p:txBody>
+          <a:bodyPr wrap="square" rtlCol="0" anchor="ctr"/>
+          <a:lstStyle/>
+          <a:p>
+            <a:pPr marL="0" indent="0" algn="ctr">
+              <a:buNone/>
+            </a:pPr>
+            <a:r>
+              <a:rPr lang="en-US" sz="1350" b="1" dirty="0">
+                <a:solidFill>
+                  <a:srgbClr val="0B1F3A"/>
+                </a:solidFill>
+                <a:latin typeface="Calibri" pitchFamily="34" charset="0"/>
+                <a:ea typeface="Calibri" pitchFamily="34" charset="-122"/>
+                <a:cs typeface="Calibri" pitchFamily="34" charset="-120"/>
+              </a:rPr>
+              <a:t>QR &amp; UPI Payment Checker</a:t>
+            </a:r>
+            <a:endParaRPr lang="en-US" sz="1350" dirty="0"/>
+          </a:p>
+        </p:txBody>
+      </p:sp>
+      <p:sp>
+        <p:nvSpPr>
+          <p:cNvPr id="23" name="Text 17"/>
+          <p:cNvSpPr/>
+          <p:nvPr/>
+        </p:nvSpPr>
+        <p:spPr>
+          <a:xfrm>
+            <a:off x="731520" y="5458968"/>
+            <a:ext cx="3154680" cy="777240"/>
+          </a:xfrm>
+          <a:prstGeom prst="rect">
+            <a:avLst/>
+          </a:prstGeom>
+          <a:noFill/>
+          <a:ln/>
+        </p:spPr>
+        <p:txBody>
+          <a:bodyPr wrap="square" rtlCol="0" anchor="t"/>
+          <a:lstStyle/>
+          <a:p>
+            <a:pPr marL="0" indent="0" algn="ctr">
+              <a:buNone/>
+            </a:pPr>
+            <a:r>
+              <a:rPr lang="en-US" sz="1050" dirty="0">
+                <a:solidFill>
+                  <a:srgbClr val="5B6B82"/>
+                </a:solidFill>
+                <a:latin typeface="Calibri" pitchFamily="34" charset="0"/>
+                <a:ea typeface="Calibri" pitchFamily="34" charset="-122"/>
+                <a:cs typeface="Calibri" pitchFamily="34" charset="-120"/>
+              </a:rPr>
+              <a:t>Decodes any payment QR on your device and shows who the money really goes to — before you pay.</a:t>
+            </a:r>
+            <a:endParaRPr lang="en-US" sz="1050" dirty="0"/>
+          </a:p>
+        </p:txBody>
+      </p:sp>
+      <p:sp>
+        <p:nvSpPr>
+          <p:cNvPr id="24" name="Shape 18"/>
+          <p:cNvSpPr/>
+          <p:nvPr/>
+        </p:nvSpPr>
+        <p:spPr>
+          <a:xfrm>
+            <a:off x="4297680" y="3977640"/>
+            <a:ext cx="3611880" cy="2331720"/>
+          </a:xfrm>
+          <a:prstGeom prst="roundRect">
+            <a:avLst>
+              <a:gd name="adj" fmla="val 3137"/>
+            </a:avLst>
+          </a:prstGeom>
+          <a:solidFill>
+            <a:srgbClr val="F4F8FC"/>
+          </a:solidFill>
+          <a:ln/>
+        </p:spPr>
+      </p:sp>
+      <p:sp>
+        <p:nvSpPr>
+          <p:cNvPr id="25" name="Shape 19"/>
+          <p:cNvSpPr/>
+          <p:nvPr/>
+        </p:nvSpPr>
+        <p:spPr>
+          <a:xfrm>
+            <a:off x="5760720" y="4233672"/>
+            <a:ext cx="685800" cy="685800"/>
+          </a:xfrm>
+          <a:prstGeom prst="ellipse">
+            <a:avLst/>
+          </a:prstGeom>
+          <a:solidFill>
+            <a:srgbClr val="2E86FF"/>
+          </a:solidFill>
+          <a:ln/>
+        </p:spPr>
+      </p:sp>
+      <p:pic>
+        <p:nvPicPr>
+          <p:cNvPr id="26" name="Image 4" descr="/home/claude/icons/gauge.png"/>
+          <p:cNvPicPr>
+            <a:picLocks noChangeAspect="1"/>
+          </p:cNvPicPr>
+          <p:nvPr/>
+        </p:nvPicPr>
+        <p:blipFill>
+          <a:blip r:embed="rId7"/>
+          <a:stretch>
+            <a:fillRect/>
+          </a:stretch>
+        </p:blipFill>
+        <p:spPr>
+          <a:xfrm>
+            <a:off x="5939028" y="4411980"/>
+            <a:ext cx="329184" cy="329184"/>
+          </a:xfrm>
+          <a:prstGeom prst="rect">
+            <a:avLst/>
+          </a:prstGeom>
+        </p:spPr>
+      </p:pic>
+      <p:sp>
+        <p:nvSpPr>
+          <p:cNvPr id="27" name="Text 20"/>
+          <p:cNvSpPr/>
+          <p:nvPr/>
+        </p:nvSpPr>
+        <p:spPr>
+          <a:xfrm>
+            <a:off x="4480560" y="5029200"/>
+            <a:ext cx="3246120" cy="457200"/>
+          </a:xfrm>
+          <a:prstGeom prst="rect">
+            <a:avLst/>
+          </a:prstGeom>
+          <a:noFill/>
+          <a:ln/>
+        </p:spPr>
+        <p:txBody>
+          <a:bodyPr wrap="square" rtlCol="0" anchor="ctr"/>
+          <a:lstStyle/>
+          <a:p>
+            <a:pPr marL="0" indent="0" algn="ctr">
+              <a:buNone/>
+            </a:pPr>
+            <a:r>
+              <a:rPr lang="en-US" sz="1350" b="1" dirty="0">
+                <a:solidFill>
+                  <a:srgbClr val="0B1F3A"/>
+                </a:solidFill>
+                <a:latin typeface="Calibri" pitchFamily="34" charset="0"/>
+                <a:ea typeface="Calibri" pitchFamily="34" charset="-122"/>
+                <a:cs typeface="Calibri" pitchFamily="34" charset="-120"/>
+              </a:rPr>
+              <a:t>Global Domain Trust</a:t>
+            </a:r>
+            <a:endParaRPr lang="en-US" sz="1350" dirty="0"/>
+          </a:p>
+        </p:txBody>
+      </p:sp>
+      <p:sp>
+        <p:nvSpPr>
+          <p:cNvPr id="28" name="Text 21"/>
+          <p:cNvSpPr/>
+          <p:nvPr/>
+        </p:nvSpPr>
+        <p:spPr>
+          <a:xfrm>
+            <a:off x="4526280" y="5458968"/>
+            <a:ext cx="3154680" cy="777240"/>
+          </a:xfrm>
+          <a:prstGeom prst="rect">
+            <a:avLst/>
+          </a:prstGeom>
+          <a:noFill/>
+          <a:ln/>
+        </p:spPr>
+        <p:txBody>
+          <a:bodyPr wrap="square" rtlCol="0" anchor="t"/>
+          <a:lstStyle/>
+          <a:p>
+            <a:pPr marL="0" indent="0" algn="ctr">
+              <a:buNone/>
+            </a:pPr>
+            <a:r>
+              <a:rPr lang="en-US" sz="1050" dirty="0">
+                <a:solidFill>
+                  <a:srgbClr val="5B6B82"/>
+                </a:solidFill>
+                <a:latin typeface="Calibri" pitchFamily="34" charset="0"/>
+                <a:ea typeface="Calibri" pitchFamily="34" charset="-122"/>
+                <a:cs typeface="Calibri" pitchFamily="34" charset="-120"/>
+              </a:rPr>
+              <a:t>Public Suffix List + the world's top-1M sites in a 1.4 MB Bloom filter — false positives engineered out.</a:t>
+            </a:r>
+            <a:endParaRPr lang="en-US" sz="1050" dirty="0"/>
+          </a:p>
+        </p:txBody>
+      </p:sp>
+      <p:sp>
+        <p:nvSpPr>
+          <p:cNvPr id="29" name="Shape 22"/>
+          <p:cNvSpPr/>
+          <p:nvPr/>
+        </p:nvSpPr>
+        <p:spPr>
+          <a:xfrm>
+            <a:off x="8092440" y="3977640"/>
+            <a:ext cx="3611880" cy="2331720"/>
+          </a:xfrm>
+          <a:prstGeom prst="roundRect">
+            <a:avLst>
+              <a:gd name="adj" fmla="val 3137"/>
+            </a:avLst>
+          </a:prstGeom>
+          <a:solidFill>
+            <a:srgbClr val="F4F8FC"/>
+          </a:solidFill>
+          <a:ln/>
+        </p:spPr>
+      </p:sp>
+      <p:sp>
+        <p:nvSpPr>
+          <p:cNvPr id="30" name="Shape 23"/>
+          <p:cNvSpPr/>
+          <p:nvPr/>
+        </p:nvSpPr>
+        <p:spPr>
+          <a:xfrm>
+            <a:off x="9555480" y="4233672"/>
+            <a:ext cx="685800" cy="685800"/>
+          </a:xfrm>
+          <a:prstGeom prst="ellipse">
+            <a:avLst/>
+          </a:prstGeom>
+          <a:solidFill>
+            <a:srgbClr val="2E86FF"/>
+          </a:solidFill>
+          <a:ln/>
+        </p:spPr>
+      </p:sp>
+      <p:pic>
+        <p:nvPicPr>
+          <p:cNvPr id="31" name="Image 5" descr="/home/claude/icons/userShield.png"/>
+          <p:cNvPicPr>
+            <a:picLocks noChangeAspect="1"/>
+          </p:cNvPicPr>
+          <p:nvPr/>
+        </p:nvPicPr>
+        <p:blipFill>
+          <a:blip r:embed="rId8"/>
+          <a:stretch>
+            <a:fillRect/>
+          </a:stretch>
+        </p:blipFill>
+        <p:spPr>
+          <a:xfrm>
+            <a:off x="9733788" y="4411980"/>
+            <a:ext cx="329184" cy="329184"/>
+          </a:xfrm>
+          <a:prstGeom prst="rect">
+            <a:avLst/>
+          </a:prstGeom>
+        </p:spPr>
+      </p:pic>
+      <p:sp>
+        <p:nvSpPr>
+          <p:cNvPr id="32" name="Text 24"/>
+          <p:cNvSpPr/>
+          <p:nvPr/>
+        </p:nvSpPr>
+        <p:spPr>
+          <a:xfrm>
+            <a:off x="8275320" y="5029200"/>
+            <a:ext cx="3246120" cy="457200"/>
+          </a:xfrm>
+          <a:prstGeom prst="rect">
+            <a:avLst/>
+          </a:prstGeom>
+          <a:noFill/>
+          <a:ln/>
+        </p:spPr>
+        <p:txBody>
+          <a:bodyPr wrap="square" rtlCol="0" anchor="ctr"/>
+          <a:lstStyle/>
+          <a:p>
+            <a:pPr marL="0" indent="0" algn="ctr">
+              <a:buNone/>
+            </a:pPr>
+            <a:r>
+              <a:rPr lang="en-US" sz="1350" b="1" dirty="0">
+                <a:solidFill>
+                  <a:srgbClr val="0B1F3A"/>
+                </a:solidFill>
+                <a:latin typeface="Calibri" pitchFamily="34" charset="0"/>
+                <a:ea typeface="Calibri" pitchFamily="34" charset="-122"/>
+                <a:cs typeface="Calibri" pitchFamily="34" charset="-120"/>
+              </a:rPr>
+              <a:t>Privacy by Architecture</a:t>
+            </a:r>
+            <a:endParaRPr lang="en-US" sz="1350" dirty="0"/>
+          </a:p>
+        </p:txBody>
+      </p:sp>
+      <p:sp>
+        <p:nvSpPr>
+          <p:cNvPr id="33" name="Text 25"/>
+          <p:cNvSpPr/>
+          <p:nvPr/>
+        </p:nvSpPr>
+        <p:spPr>
+          <a:xfrm>
+            <a:off x="8321040" y="5458968"/>
+            <a:ext cx="3154680" cy="777240"/>
+          </a:xfrm>
+          <a:prstGeom prst="rect">
+            <a:avLst/>
+          </a:prstGeom>
+          <a:noFill/>
+          <a:ln/>
+        </p:spPr>
+        <p:txBody>
+          <a:bodyPr wrap="square" rtlCol="0" anchor="t"/>
+          <a:lstStyle/>
+          <a:p>
+            <a:pPr marL="0" indent="0" algn="ctr">
+              <a:buNone/>
+            </a:pPr>
+            <a:r>
+              <a:rPr lang="en-US" sz="1050" dirty="0">
+                <a:solidFill>
+                  <a:srgbClr val="5B6B82"/>
+                </a:solidFill>
+                <a:latin typeface="Calibri" pitchFamily="34" charset="0"/>
+                <a:ea typeface="Calibri" pitchFamily="34" charset="-122"/>
+                <a:cs typeface="Calibri" pitchFamily="34" charset="-120"/>
+              </a:rPr>
+              <a:t>Zero network calls, no account, no telemetry — links, messages and QR photos never leave the browser.</a:t>
+            </a:r>
+            <a:endParaRPr lang="en-US" sz="1050" dirty="0"/>
           </a:p>
         </p:txBody>
       </p:sp>
@@ -5503,7 +6462,7 @@
                 <a:ea typeface="Calibri" pitchFamily="34" charset="-122"/>
                 <a:cs typeface="Calibri" pitchFamily="34" charset="-120"/>
               </a:rPr>
-              <a:t>Delivered the real-time API and live dashboard — URL accuracy 98.60%, email accuracy 99.33%.</a:t>
+              <a:t>Shipped the Scam Shield extension, real-time API and dashboard — 98.6% / 99.3% accuracy.</a:t>
             </a:r>
             <a:endParaRPr lang="en-US" sz="1150" dirty="0"/>
           </a:p>
@@ -5667,7 +6626,7 @@
                 <a:ea typeface="Calibri" pitchFamily="34" charset="-122"/>
                 <a:cs typeface="Calibri" pitchFamily="34" charset="-120"/>
               </a:rPr>
-              <a:t>Add live reputation feeds (PhishTank / OpenPhish) and page-content signals to URL analysis.</a:t>
+              <a:t>Publish to the Chrome Web Store; port to Firefox and Edge.</a:t>
             </a:r>
             <a:endParaRPr lang="en-US" sz="1150" dirty="0"/>
           </a:p>
@@ -5726,7 +6685,7 @@
                 <a:ea typeface="Calibri" pitchFamily="34" charset="-122"/>
                 <a:cs typeface="Calibri" pitchFamily="34" charset="-120"/>
               </a:rPr>
-              <a:t>Add a transformer (DistilBERT) ensemble member and a stacking meta-learner.</a:t>
+              <a:t>Multilingual scam packs — Hindi, Telugu and Tamil message analysis.</a:t>
             </a:r>
             <a:endParaRPr lang="en-US" sz="1150" dirty="0"/>
           </a:p>
@@ -5785,7 +6744,7 @@
                 <a:ea typeface="Calibri" pitchFamily="34" charset="-122"/>
                 <a:cs typeface="Calibri" pitchFamily="34" charset="-120"/>
               </a:rPr>
-              <a:t>Publish the shipped Chrome extension to the Web Store; add a mail-gateway hook.</a:t>
+              <a:t>Android share-target app — check a WhatsApp message in one tap.</a:t>
             </a:r>
             <a:endParaRPr lang="en-US" sz="1150" dirty="0"/>
           </a:p>
@@ -5844,7 +6803,7 @@
                 <a:ea typeface="Calibri" pitchFamily="34" charset="-122"/>
                 <a:cs typeface="Calibri" pitchFamily="34" charset="-120"/>
               </a:rPr>
-              <a:t>Close the loop: analyst feedback feeding one-command periodic retraining.</a:t>
+              <a:t>Family tier: protect parents from your phone, with privacy intact.</a:t>
             </a:r>
             <a:endParaRPr lang="en-US" sz="1150" dirty="0"/>
           </a:p>

</xml_diff>